<commit_message>
SEO, FAQ-schema, mobil menu, robots.txt fix
- SEO: robots.txt, sitemap.xml, canonical på alle sider, JSON-LD (Organization, WebSite, WebApplication, FAQPage), middleware 301 www
- FAQ: Ofte stillede spørgsmål på forsiden + FAQPage schema
- Mobil/tablet: Hamburger-menu med slide-in panel (Forside, Artikler, Beregn)
- robots.txt: Disallow /go (dækker /go og /go/*)

Made-with: Cursor
</commit_message>
<xml_diff>
--- a/Brand Identity & Logo/Boligklarhed Logo PP.pptx
+++ b/Brand Identity & Logo/Boligklarhed Logo PP.pptx
@@ -7,14 +7,14 @@
   <p:sldIdLst>
     <p:sldId id="256" r:id="rId2"/>
   </p:sldIdLst>
-  <p:sldSz cx="7199313" cy="7199313"/>
+  <p:sldSz cx="6478588" cy="2879725"/>
   <p:notesSz cx="6858000" cy="9144000"/>
   <p:defaultTextStyle>
     <a:defPPr>
       <a:defRPr lang="en-DK"/>
     </a:defPPr>
-    <a:lvl1pPr marL="0" algn="l" defTabSz="691113" rtl="0" eaLnBrk="1" latinLnBrk="0" hangingPunct="1">
-      <a:defRPr sz="1360" kern="1200">
+    <a:lvl1pPr marL="0" algn="l" defTabSz="598849" rtl="0" eaLnBrk="1" latinLnBrk="0" hangingPunct="1">
+      <a:defRPr sz="1178" kern="1200">
         <a:solidFill>
           <a:schemeClr val="tx1"/>
         </a:solidFill>
@@ -23,8 +23,8 @@
         <a:cs typeface="+mn-cs"/>
       </a:defRPr>
     </a:lvl1pPr>
-    <a:lvl2pPr marL="345558" algn="l" defTabSz="691113" rtl="0" eaLnBrk="1" latinLnBrk="0" hangingPunct="1">
-      <a:defRPr sz="1360" kern="1200">
+    <a:lvl2pPr marL="299426" algn="l" defTabSz="598849" rtl="0" eaLnBrk="1" latinLnBrk="0" hangingPunct="1">
+      <a:defRPr sz="1178" kern="1200">
         <a:solidFill>
           <a:schemeClr val="tx1"/>
         </a:solidFill>
@@ -33,8 +33,8 @@
         <a:cs typeface="+mn-cs"/>
       </a:defRPr>
     </a:lvl2pPr>
-    <a:lvl3pPr marL="691113" algn="l" defTabSz="691113" rtl="0" eaLnBrk="1" latinLnBrk="0" hangingPunct="1">
-      <a:defRPr sz="1360" kern="1200">
+    <a:lvl3pPr marL="598849" algn="l" defTabSz="598849" rtl="0" eaLnBrk="1" latinLnBrk="0" hangingPunct="1">
+      <a:defRPr sz="1178" kern="1200">
         <a:solidFill>
           <a:schemeClr val="tx1"/>
         </a:solidFill>
@@ -43,8 +43,8 @@
         <a:cs typeface="+mn-cs"/>
       </a:defRPr>
     </a:lvl3pPr>
-    <a:lvl4pPr marL="1036671" algn="l" defTabSz="691113" rtl="0" eaLnBrk="1" latinLnBrk="0" hangingPunct="1">
-      <a:defRPr sz="1360" kern="1200">
+    <a:lvl4pPr marL="898275" algn="l" defTabSz="598849" rtl="0" eaLnBrk="1" latinLnBrk="0" hangingPunct="1">
+      <a:defRPr sz="1178" kern="1200">
         <a:solidFill>
           <a:schemeClr val="tx1"/>
         </a:solidFill>
@@ -53,8 +53,8 @@
         <a:cs typeface="+mn-cs"/>
       </a:defRPr>
     </a:lvl4pPr>
-    <a:lvl5pPr marL="1382226" algn="l" defTabSz="691113" rtl="0" eaLnBrk="1" latinLnBrk="0" hangingPunct="1">
-      <a:defRPr sz="1360" kern="1200">
+    <a:lvl5pPr marL="1197699" algn="l" defTabSz="598849" rtl="0" eaLnBrk="1" latinLnBrk="0" hangingPunct="1">
+      <a:defRPr sz="1178" kern="1200">
         <a:solidFill>
           <a:schemeClr val="tx1"/>
         </a:solidFill>
@@ -63,8 +63,8 @@
         <a:cs typeface="+mn-cs"/>
       </a:defRPr>
     </a:lvl5pPr>
-    <a:lvl6pPr marL="1727784" algn="l" defTabSz="691113" rtl="0" eaLnBrk="1" latinLnBrk="0" hangingPunct="1">
-      <a:defRPr sz="1360" kern="1200">
+    <a:lvl6pPr marL="1497125" algn="l" defTabSz="598849" rtl="0" eaLnBrk="1" latinLnBrk="0" hangingPunct="1">
+      <a:defRPr sz="1178" kern="1200">
         <a:solidFill>
           <a:schemeClr val="tx1"/>
         </a:solidFill>
@@ -73,8 +73,8 @@
         <a:cs typeface="+mn-cs"/>
       </a:defRPr>
     </a:lvl6pPr>
-    <a:lvl7pPr marL="2073342" algn="l" defTabSz="691113" rtl="0" eaLnBrk="1" latinLnBrk="0" hangingPunct="1">
-      <a:defRPr sz="1360" kern="1200">
+    <a:lvl7pPr marL="1796551" algn="l" defTabSz="598849" rtl="0" eaLnBrk="1" latinLnBrk="0" hangingPunct="1">
+      <a:defRPr sz="1178" kern="1200">
         <a:solidFill>
           <a:schemeClr val="tx1"/>
         </a:solidFill>
@@ -83,8 +83,8 @@
         <a:cs typeface="+mn-cs"/>
       </a:defRPr>
     </a:lvl7pPr>
-    <a:lvl8pPr marL="2418897" algn="l" defTabSz="691113" rtl="0" eaLnBrk="1" latinLnBrk="0" hangingPunct="1">
-      <a:defRPr sz="1360" kern="1200">
+    <a:lvl8pPr marL="2095974" algn="l" defTabSz="598849" rtl="0" eaLnBrk="1" latinLnBrk="0" hangingPunct="1">
+      <a:defRPr sz="1178" kern="1200">
         <a:solidFill>
           <a:schemeClr val="tx1"/>
         </a:solidFill>
@@ -93,8 +93,8 @@
         <a:cs typeface="+mn-cs"/>
       </a:defRPr>
     </a:lvl8pPr>
-    <a:lvl9pPr marL="2764455" algn="l" defTabSz="691113" rtl="0" eaLnBrk="1" latinLnBrk="0" hangingPunct="1">
-      <a:defRPr sz="1360" kern="1200">
+    <a:lvl9pPr marL="2395400" algn="l" defTabSz="598849" rtl="0" eaLnBrk="1" latinLnBrk="0" hangingPunct="1">
+      <a:defRPr sz="1178" kern="1200">
         <a:solidFill>
           <a:schemeClr val="tx1"/>
         </a:solidFill>
@@ -147,8 +147,8 @@
         </p:nvSpPr>
         <p:spPr>
           <a:xfrm>
-            <a:off x="899914" y="1178223"/>
-            <a:ext cx="5399486" cy="2506427"/>
+            <a:off x="809823" y="471289"/>
+            <a:ext cx="4858942" cy="1002571"/>
           </a:xfrm>
         </p:spPr>
         <p:txBody>
@@ -185,8 +185,8 @@
         </p:nvSpPr>
         <p:spPr>
           <a:xfrm>
-            <a:off x="899914" y="3781307"/>
-            <a:ext cx="5399486" cy="1738167"/>
+            <a:off x="809823" y="1512524"/>
+            <a:ext cx="4858942" cy="695267"/>
           </a:xfrm>
         </p:spPr>
         <p:txBody>
@@ -569,8 +569,8 @@
         </p:nvSpPr>
         <p:spPr>
           <a:xfrm>
-            <a:off x="5152009" y="383299"/>
-            <a:ext cx="1552352" cy="6101085"/>
+            <a:off x="4636240" y="153320"/>
+            <a:ext cx="1396946" cy="2440434"/>
           </a:xfrm>
         </p:spPr>
         <p:txBody>
@@ -603,8 +603,8 @@
         </p:nvSpPr>
         <p:spPr>
           <a:xfrm>
-            <a:off x="494954" y="383299"/>
-            <a:ext cx="4567063" cy="6101085"/>
+            <a:off x="445405" y="153320"/>
+            <a:ext cx="4109853" cy="2440434"/>
           </a:xfrm>
         </p:spPr>
         <p:txBody>
@@ -979,8 +979,8 @@
         </p:nvSpPr>
         <p:spPr>
           <a:xfrm>
-            <a:off x="491204" y="1794831"/>
-            <a:ext cx="6209407" cy="2994714"/>
+            <a:off x="442030" y="717933"/>
+            <a:ext cx="5587782" cy="1197885"/>
           </a:xfrm>
         </p:spPr>
         <p:txBody>
@@ -1017,8 +1017,8 @@
         </p:nvSpPr>
         <p:spPr>
           <a:xfrm>
-            <a:off x="491204" y="4817874"/>
-            <a:ext cx="6209407" cy="1574849"/>
+            <a:off x="442030" y="1927150"/>
+            <a:ext cx="5587782" cy="629939"/>
           </a:xfrm>
         </p:spPr>
         <p:txBody>
@@ -1284,8 +1284,8 @@
         </p:nvSpPr>
         <p:spPr>
           <a:xfrm>
-            <a:off x="494954" y="1916484"/>
-            <a:ext cx="3059708" cy="4567897"/>
+            <a:off x="445404" y="766593"/>
+            <a:ext cx="2753400" cy="1827159"/>
           </a:xfrm>
         </p:spPr>
         <p:txBody>
@@ -1347,8 +1347,8 @@
         </p:nvSpPr>
         <p:spPr>
           <a:xfrm>
-            <a:off x="3644653" y="1916484"/>
-            <a:ext cx="3059708" cy="4567897"/>
+            <a:off x="3279786" y="766593"/>
+            <a:ext cx="2753400" cy="1827159"/>
           </a:xfrm>
         </p:spPr>
         <p:txBody>
@@ -1523,8 +1523,8 @@
         </p:nvSpPr>
         <p:spPr>
           <a:xfrm>
-            <a:off x="495891" y="383299"/>
-            <a:ext cx="6209407" cy="1391535"/>
+            <a:off x="446248" y="153320"/>
+            <a:ext cx="5587782" cy="556614"/>
           </a:xfrm>
         </p:spPr>
         <p:txBody>
@@ -1557,8 +1557,8 @@
         </p:nvSpPr>
         <p:spPr>
           <a:xfrm>
-            <a:off x="495891" y="1764831"/>
-            <a:ext cx="3045647" cy="864917"/>
+            <a:off x="446247" y="705932"/>
+            <a:ext cx="2740747" cy="345967"/>
           </a:xfrm>
         </p:spPr>
         <p:txBody>
@@ -1628,8 +1628,8 @@
         </p:nvSpPr>
         <p:spPr>
           <a:xfrm>
-            <a:off x="495891" y="2629749"/>
-            <a:ext cx="3045647" cy="3867965"/>
+            <a:off x="446247" y="1051900"/>
+            <a:ext cx="2740747" cy="1547186"/>
           </a:xfrm>
         </p:spPr>
         <p:txBody>
@@ -1691,8 +1691,8 @@
         </p:nvSpPr>
         <p:spPr>
           <a:xfrm>
-            <a:off x="3644653" y="1764831"/>
-            <a:ext cx="3060645" cy="864917"/>
+            <a:off x="3279786" y="705932"/>
+            <a:ext cx="2754243" cy="345967"/>
           </a:xfrm>
         </p:spPr>
         <p:txBody>
@@ -1762,8 +1762,8 @@
         </p:nvSpPr>
         <p:spPr>
           <a:xfrm>
-            <a:off x="3644653" y="2629749"/>
-            <a:ext cx="3060645" cy="3867965"/>
+            <a:off x="3279786" y="1051900"/>
+            <a:ext cx="2754243" cy="1547186"/>
           </a:xfrm>
         </p:spPr>
         <p:txBody>
@@ -2193,8 +2193,8 @@
         </p:nvSpPr>
         <p:spPr>
           <a:xfrm>
-            <a:off x="495892" y="479955"/>
-            <a:ext cx="2321966" cy="1679840"/>
+            <a:off x="446248" y="191982"/>
+            <a:ext cx="2089513" cy="671936"/>
           </a:xfrm>
         </p:spPr>
         <p:txBody>
@@ -2231,8 +2231,8 @@
         </p:nvSpPr>
         <p:spPr>
           <a:xfrm>
-            <a:off x="3060645" y="1036569"/>
-            <a:ext cx="3644653" cy="5116178"/>
+            <a:off x="2754244" y="414628"/>
+            <a:ext cx="3279786" cy="2046471"/>
           </a:xfrm>
         </p:spPr>
         <p:txBody>
@@ -2322,8 +2322,8 @@
         </p:nvSpPr>
         <p:spPr>
           <a:xfrm>
-            <a:off x="495892" y="2159794"/>
-            <a:ext cx="2321966" cy="4001286"/>
+            <a:off x="446248" y="863918"/>
+            <a:ext cx="2089513" cy="1600514"/>
           </a:xfrm>
         </p:spPr>
         <p:txBody>
@@ -2506,8 +2506,8 @@
         </p:nvSpPr>
         <p:spPr>
           <a:xfrm>
-            <a:off x="495892" y="479955"/>
-            <a:ext cx="2321966" cy="1679840"/>
+            <a:off x="446248" y="191982"/>
+            <a:ext cx="2089513" cy="671936"/>
           </a:xfrm>
         </p:spPr>
         <p:txBody>
@@ -2544,8 +2544,8 @@
         </p:nvSpPr>
         <p:spPr>
           <a:xfrm>
-            <a:off x="3060645" y="1036569"/>
-            <a:ext cx="3644653" cy="5116178"/>
+            <a:off x="2754244" y="414628"/>
+            <a:ext cx="3279786" cy="2046471"/>
           </a:xfrm>
         </p:spPr>
         <p:txBody>
@@ -2611,8 +2611,8 @@
         </p:nvSpPr>
         <p:spPr>
           <a:xfrm>
-            <a:off x="495892" y="2159794"/>
-            <a:ext cx="2321966" cy="4001286"/>
+            <a:off x="446248" y="863918"/>
+            <a:ext cx="2089513" cy="1600514"/>
           </a:xfrm>
         </p:spPr>
         <p:txBody>
@@ -2800,8 +2800,8 @@
         </p:nvSpPr>
         <p:spPr>
           <a:xfrm>
-            <a:off x="494953" y="383299"/>
-            <a:ext cx="6209407" cy="1391535"/>
+            <a:off x="445403" y="153320"/>
+            <a:ext cx="5587782" cy="556614"/>
           </a:xfrm>
           <a:prstGeom prst="rect">
             <a:avLst/>
@@ -2839,8 +2839,8 @@
         </p:nvSpPr>
         <p:spPr>
           <a:xfrm>
-            <a:off x="494953" y="1916484"/>
-            <a:ext cx="6209407" cy="4567897"/>
+            <a:off x="445403" y="766593"/>
+            <a:ext cx="5587782" cy="1827159"/>
           </a:xfrm>
           <a:prstGeom prst="rect">
             <a:avLst/>
@@ -2907,8 +2907,8 @@
         </p:nvSpPr>
         <p:spPr>
           <a:xfrm>
-            <a:off x="494954" y="6672698"/>
-            <a:ext cx="1619845" cy="383298"/>
+            <a:off x="445404" y="2669080"/>
+            <a:ext cx="1457682" cy="153319"/>
           </a:xfrm>
           <a:prstGeom prst="rect">
             <a:avLst/>
@@ -2954,8 +2954,8 @@
         </p:nvSpPr>
         <p:spPr>
           <a:xfrm>
-            <a:off x="2384773" y="6672698"/>
-            <a:ext cx="2429768" cy="383298"/>
+            <a:off x="2146033" y="2669080"/>
+            <a:ext cx="2186523" cy="153319"/>
           </a:xfrm>
           <a:prstGeom prst="rect">
             <a:avLst/>
@@ -2997,8 +2997,8 @@
         </p:nvSpPr>
         <p:spPr>
           <a:xfrm>
-            <a:off x="5084516" y="6672698"/>
-            <a:ext cx="1619845" cy="383298"/>
+            <a:off x="4575505" y="2669080"/>
+            <a:ext cx="1457682" cy="153319"/>
           </a:xfrm>
           <a:prstGeom prst="rect">
             <a:avLst/>
@@ -3349,10 +3349,10 @@
       </p:grpSpPr>
       <p:grpSp>
         <p:nvGrpSpPr>
-          <p:cNvPr id="3" name="Group 2">
-            <a:extLst>
-              <a:ext uri="{FF2B5EF4-FFF2-40B4-BE49-F238E27FC236}">
-                <a16:creationId xmlns:a16="http://schemas.microsoft.com/office/drawing/2014/main" id="{9BB98694-82EE-69A6-3DBA-A482859BA762}"/>
+          <p:cNvPr id="22" name="Group 21">
+            <a:extLst>
+              <a:ext uri="{FF2B5EF4-FFF2-40B4-BE49-F238E27FC236}">
+                <a16:creationId xmlns:a16="http://schemas.microsoft.com/office/drawing/2014/main" id="{02B9B2B0-AEB0-A9F2-8932-9B50264B32DE}"/>
               </a:ext>
             </a:extLst>
           </p:cNvPr>
@@ -3361,59 +3361,18 @@
         </p:nvGrpSpPr>
         <p:grpSpPr>
           <a:xfrm>
-            <a:off x="961494" y="3076372"/>
-            <a:ext cx="5276324" cy="1152415"/>
-            <a:chOff x="1426128" y="2536167"/>
-            <a:chExt cx="5276324" cy="1152415"/>
+            <a:off x="526297" y="846292"/>
+            <a:ext cx="5425999" cy="1187140"/>
+            <a:chOff x="886658" y="3053222"/>
+            <a:chExt cx="5425999" cy="1187140"/>
           </a:xfrm>
         </p:grpSpPr>
-        <p:sp>
-          <p:nvSpPr>
-            <p:cNvPr id="4" name="TextBox 3">
+        <p:grpSp>
+          <p:nvGrpSpPr>
+            <p:cNvPr id="3" name="Group 2">
               <a:extLst>
                 <a:ext uri="{FF2B5EF4-FFF2-40B4-BE49-F238E27FC236}">
-                  <a16:creationId xmlns:a16="http://schemas.microsoft.com/office/drawing/2014/main" id="{B38A98D1-E084-CB78-D359-ABE8DE777E15}"/>
-                </a:ext>
-              </a:extLst>
-            </p:cNvPr>
-            <p:cNvSpPr txBox="1"/>
-            <p:nvPr/>
-          </p:nvSpPr>
-          <p:spPr>
-            <a:xfrm>
-              <a:off x="2310855" y="2536167"/>
-              <a:ext cx="4379874" cy="923330"/>
-            </a:xfrm>
-            <a:prstGeom prst="rect">
-              <a:avLst/>
-            </a:prstGeom>
-            <a:noFill/>
-          </p:spPr>
-          <p:txBody>
-            <a:bodyPr wrap="none" lIns="90000" rtlCol="0">
-              <a:spAutoFit/>
-            </a:bodyPr>
-            <a:lstStyle/>
-            <a:p>
-              <a:r>
-                <a:rPr lang="en-DK" sz="5400" b="1" dirty="0">
-                  <a:solidFill>
-                    <a:srgbClr val="1E395F"/>
-                  </a:solidFill>
-                  <a:latin typeface="Inter SemiBold" panose="02000503000000020004" pitchFamily="2" charset="0"/>
-                  <a:ea typeface="Inter SemiBold" panose="02000503000000020004" pitchFamily="2" charset="0"/>
-                </a:rPr>
-                <a:t>Boligklarhed</a:t>
-              </a:r>
-            </a:p>
-          </p:txBody>
-        </p:sp>
-        <p:grpSp>
-          <p:nvGrpSpPr>
-            <p:cNvPr id="2" name="Group 1">
-              <a:extLst>
-                <a:ext uri="{FF2B5EF4-FFF2-40B4-BE49-F238E27FC236}">
-                  <a16:creationId xmlns:a16="http://schemas.microsoft.com/office/drawing/2014/main" id="{9198CC8F-8364-72B1-8757-F6A384F2ECCD}"/>
+                  <a16:creationId xmlns:a16="http://schemas.microsoft.com/office/drawing/2014/main" id="{9BB98694-82EE-69A6-3DBA-A482859BA762}"/>
                 </a:ext>
               </a:extLst>
             </p:cNvPr>
@@ -3422,12 +3381,63 @@
           </p:nvGrpSpPr>
           <p:grpSpPr>
             <a:xfrm>
-              <a:off x="1426128" y="2636318"/>
-              <a:ext cx="840346" cy="963338"/>
-              <a:chOff x="1534367" y="2832437"/>
-              <a:chExt cx="670173" cy="768258"/>
+              <a:off x="886658" y="3053222"/>
+              <a:ext cx="5425999" cy="1187140"/>
+              <a:chOff x="1351292" y="2513017"/>
+              <a:chExt cx="5425999" cy="1187140"/>
             </a:xfrm>
           </p:grpSpPr>
+          <p:sp>
+            <p:nvSpPr>
+              <p:cNvPr id="4" name="TextBox 3">
+                <a:extLst>
+                  <a:ext uri="{FF2B5EF4-FFF2-40B4-BE49-F238E27FC236}">
+                    <a16:creationId xmlns:a16="http://schemas.microsoft.com/office/drawing/2014/main" id="{B38A98D1-E084-CB78-D359-ABE8DE777E15}"/>
+                  </a:ext>
+                </a:extLst>
+              </p:cNvPr>
+              <p:cNvSpPr txBox="1"/>
+              <p:nvPr/>
+            </p:nvSpPr>
+            <p:spPr>
+              <a:xfrm>
+                <a:off x="2310855" y="2513017"/>
+                <a:ext cx="4466436" cy="923330"/>
+              </a:xfrm>
+              <a:prstGeom prst="rect">
+                <a:avLst/>
+              </a:prstGeom>
+              <a:noFill/>
+            </p:spPr>
+            <p:txBody>
+              <a:bodyPr wrap="none" lIns="90000" rtlCol="0">
+                <a:spAutoFit/>
+              </a:bodyPr>
+              <a:lstStyle/>
+              <a:p>
+                <a:r>
+                  <a:rPr lang="en-DK" sz="5400" dirty="0">
+                    <a:solidFill>
+                      <a:srgbClr val="1E395F"/>
+                    </a:solidFill>
+                    <a:latin typeface="Inter Medium" panose="02000503000000020004" pitchFamily="2" charset="0"/>
+                    <a:ea typeface="Inter Medium" panose="02000503000000020004" pitchFamily="2" charset="0"/>
+                  </a:rPr>
+                  <a:t>Bolig</a:t>
+                </a:r>
+                <a:r>
+                  <a:rPr lang="en-DK" sz="5400" b="1" dirty="0">
+                    <a:solidFill>
+                      <a:srgbClr val="1E395F"/>
+                    </a:solidFill>
+                    <a:latin typeface="Inter ExtraBold" panose="02000503000000020004" pitchFamily="2" charset="0"/>
+                    <a:ea typeface="Inter ExtraBold" panose="02000503000000020004" pitchFamily="2" charset="0"/>
+                  </a:rPr>
+                  <a:t>klarhed</a:t>
+                </a:r>
+              </a:p>
+            </p:txBody>
+          </p:sp>
           <p:grpSp>
             <p:nvGrpSpPr>
               <p:cNvPr id="13" name="Group 12">
@@ -3442,9 +3452,9 @@
             </p:nvGrpSpPr>
             <p:grpSpPr>
               <a:xfrm>
-                <a:off x="1534367" y="2832437"/>
-                <a:ext cx="670173" cy="768258"/>
-                <a:chOff x="950299" y="4444772"/>
+                <a:off x="1351292" y="2636318"/>
+                <a:ext cx="840347" cy="963338"/>
+                <a:chOff x="899420" y="4444772"/>
                 <a:chExt cx="571292" cy="654905"/>
               </a:xfrm>
             </p:grpSpPr>
@@ -3462,7 +3472,7 @@
               </p:nvSpPr>
               <p:spPr>
                 <a:xfrm>
-                  <a:off x="950299" y="4690540"/>
+                  <a:off x="899420" y="4690540"/>
                   <a:ext cx="571292" cy="409137"/>
                 </a:xfrm>
                 <a:prstGeom prst="rect">
@@ -3514,7 +3524,7 @@
               </p:nvSpPr>
               <p:spPr>
                 <a:xfrm>
-                  <a:off x="950299" y="4444772"/>
+                  <a:off x="899420" y="4444772"/>
                   <a:ext cx="571292" cy="245768"/>
                 </a:xfrm>
                 <a:prstGeom prst="triangle">
@@ -3552,293 +3562,93 @@
                 </a:p>
               </p:txBody>
             </p:sp>
-            <p:sp>
-              <p:nvSpPr>
-                <p:cNvPr id="9" name="Rectangle 8">
-                  <a:extLst>
-                    <a:ext uri="{FF2B5EF4-FFF2-40B4-BE49-F238E27FC236}">
-                      <a16:creationId xmlns:a16="http://schemas.microsoft.com/office/drawing/2014/main" id="{980A54BC-8D0A-1D90-2234-BD69D1617ED4}"/>
-                    </a:ext>
-                  </a:extLst>
-                </p:cNvPr>
-                <p:cNvSpPr/>
-                <p:nvPr/>
-              </p:nvSpPr>
-              <p:spPr>
-                <a:xfrm>
-                  <a:off x="1155533" y="4851399"/>
-                  <a:ext cx="160824" cy="245768"/>
-                </a:xfrm>
-                <a:prstGeom prst="rect">
-                  <a:avLst/>
-                </a:prstGeom>
-                <a:solidFill>
-                  <a:schemeClr val="bg1"/>
-                </a:solidFill>
-                <a:ln>
-                  <a:noFill/>
-                </a:ln>
-              </p:spPr>
-              <p:style>
-                <a:lnRef idx="2">
-                  <a:schemeClr val="accent1">
-                    <a:shade val="15000"/>
-                  </a:schemeClr>
-                </a:lnRef>
-                <a:fillRef idx="1">
-                  <a:schemeClr val="accent1"/>
-                </a:fillRef>
-                <a:effectRef idx="0">
-                  <a:schemeClr val="accent1"/>
-                </a:effectRef>
-                <a:fontRef idx="minor">
-                  <a:schemeClr val="lt1"/>
-                </a:fontRef>
-              </p:style>
-              <p:txBody>
-                <a:bodyPr rtlCol="0" anchor="ctr"/>
-                <a:lstStyle/>
-                <a:p>
-                  <a:pPr algn="ctr"/>
-                  <a:endParaRPr lang="en-DK"/>
-                </a:p>
-              </p:txBody>
-            </p:sp>
-            <p:sp>
-              <p:nvSpPr>
-                <p:cNvPr id="12" name="Rectangle 11">
-                  <a:extLst>
-                    <a:ext uri="{FF2B5EF4-FFF2-40B4-BE49-F238E27FC236}">
-                      <a16:creationId xmlns:a16="http://schemas.microsoft.com/office/drawing/2014/main" id="{F37A4F0B-2F0D-5F38-3BBE-F35A1B985B08}"/>
-                    </a:ext>
-                  </a:extLst>
-                </p:cNvPr>
-                <p:cNvSpPr>
-                  <a:spLocks noChangeAspect="1"/>
-                </p:cNvSpPr>
-                <p:nvPr/>
-              </p:nvSpPr>
-              <p:spPr>
-                <a:xfrm>
-                  <a:off x="1020414" y="4732463"/>
-                  <a:ext cx="92065" cy="92065"/>
-                </a:xfrm>
-                <a:prstGeom prst="rect">
-                  <a:avLst/>
-                </a:prstGeom>
-                <a:solidFill>
-                  <a:schemeClr val="bg1"/>
-                </a:solidFill>
-                <a:ln>
-                  <a:noFill/>
-                </a:ln>
-              </p:spPr>
-              <p:style>
-                <a:lnRef idx="2">
-                  <a:schemeClr val="accent1">
-                    <a:shade val="15000"/>
-                  </a:schemeClr>
-                </a:lnRef>
-                <a:fillRef idx="1">
-                  <a:schemeClr val="accent1"/>
-                </a:fillRef>
-                <a:effectRef idx="0">
-                  <a:schemeClr val="accent1"/>
-                </a:effectRef>
-                <a:fontRef idx="minor">
-                  <a:schemeClr val="lt1"/>
-                </a:fontRef>
-              </p:style>
-              <p:txBody>
-                <a:bodyPr rtlCol="0" anchor="ctr"/>
-                <a:lstStyle/>
-                <a:p>
-                  <a:pPr algn="ctr"/>
-                  <a:endParaRPr lang="en-DK"/>
-                </a:p>
-              </p:txBody>
-            </p:sp>
           </p:grpSp>
-          <p:grpSp>
-            <p:nvGrpSpPr>
-              <p:cNvPr id="16" name="Group 15">
+          <p:sp>
+            <p:nvSpPr>
+              <p:cNvPr id="17" name="TextBox 16">
                 <a:extLst>
                   <a:ext uri="{FF2B5EF4-FFF2-40B4-BE49-F238E27FC236}">
-                    <a16:creationId xmlns:a16="http://schemas.microsoft.com/office/drawing/2014/main" id="{27A602D3-AC8E-1FD8-4D44-7EE8106FF2AD}"/>
+                    <a16:creationId xmlns:a16="http://schemas.microsoft.com/office/drawing/2014/main" id="{13B25C3B-935B-2D44-1A53-1FC9E7B5B936}"/>
                   </a:ext>
                 </a:extLst>
               </p:cNvPr>
-              <p:cNvGrpSpPr>
-                <a:grpSpLocks noChangeAspect="1"/>
-              </p:cNvGrpSpPr>
+              <p:cNvSpPr txBox="1"/>
               <p:nvPr/>
-            </p:nvGrpSpPr>
-            <p:grpSpPr>
+            </p:nvSpPr>
+            <p:spPr>
               <a:xfrm>
-                <a:off x="1814664" y="3331793"/>
-                <a:ext cx="109577" cy="180000"/>
-                <a:chOff x="2774732" y="3048000"/>
-                <a:chExt cx="216000" cy="354819"/>
+                <a:off x="2346023" y="3300047"/>
+                <a:ext cx="4356429" cy="400110"/>
               </a:xfrm>
-              <a:solidFill>
-                <a:srgbClr val="1E395F"/>
-              </a:solidFill>
-            </p:grpSpPr>
-            <p:sp>
-              <p:nvSpPr>
-                <p:cNvPr id="14" name="Oval 13">
-                  <a:extLst>
-                    <a:ext uri="{FF2B5EF4-FFF2-40B4-BE49-F238E27FC236}">
-                      <a16:creationId xmlns:a16="http://schemas.microsoft.com/office/drawing/2014/main" id="{0DFE7ADB-B107-0D5D-C198-DC231E81499A}"/>
-                    </a:ext>
-                  </a:extLst>
-                </p:cNvPr>
-                <p:cNvSpPr>
-                  <a:spLocks noChangeAspect="1"/>
-                </p:cNvSpPr>
-                <p:nvPr/>
-              </p:nvSpPr>
-              <p:spPr>
-                <a:xfrm>
-                  <a:off x="2774732" y="3048000"/>
-                  <a:ext cx="216000" cy="216000"/>
-                </a:xfrm>
-                <a:prstGeom prst="ellipse">
-                  <a:avLst/>
-                </a:prstGeom>
-                <a:grpFill/>
-                <a:ln>
-                  <a:noFill/>
-                </a:ln>
-              </p:spPr>
-              <p:style>
-                <a:lnRef idx="2">
-                  <a:schemeClr val="accent1">
-                    <a:shade val="15000"/>
-                  </a:schemeClr>
-                </a:lnRef>
-                <a:fillRef idx="1">
-                  <a:schemeClr val="accent1"/>
-                </a:fillRef>
-                <a:effectRef idx="0">
-                  <a:schemeClr val="accent1"/>
-                </a:effectRef>
-                <a:fontRef idx="minor">
-                  <a:schemeClr val="lt1"/>
-                </a:fontRef>
-              </p:style>
-              <p:txBody>
-                <a:bodyPr rtlCol="0" anchor="ctr"/>
-                <a:lstStyle/>
-                <a:p>
-                  <a:pPr algn="ctr"/>
-                  <a:endParaRPr lang="en-DK"/>
-                </a:p>
-              </p:txBody>
-            </p:sp>
-            <p:sp>
-              <p:nvSpPr>
-                <p:cNvPr id="15" name="Trapezium 14">
-                  <a:extLst>
-                    <a:ext uri="{FF2B5EF4-FFF2-40B4-BE49-F238E27FC236}">
-                      <a16:creationId xmlns:a16="http://schemas.microsoft.com/office/drawing/2014/main" id="{7513A94D-D7D7-597D-EE92-62808E1D7289}"/>
-                    </a:ext>
-                  </a:extLst>
-                </p:cNvPr>
-                <p:cNvSpPr/>
-                <p:nvPr/>
-              </p:nvSpPr>
-              <p:spPr>
-                <a:xfrm>
-                  <a:off x="2800014" y="3176846"/>
-                  <a:ext cx="165436" cy="225973"/>
-                </a:xfrm>
-                <a:prstGeom prst="trapezoid">
-                  <a:avLst>
-                    <a:gd name="adj" fmla="val 27670"/>
-                  </a:avLst>
-                </a:prstGeom>
-                <a:grpFill/>
-                <a:ln>
-                  <a:noFill/>
-                </a:ln>
-              </p:spPr>
-              <p:style>
-                <a:lnRef idx="2">
-                  <a:schemeClr val="accent1">
-                    <a:shade val="15000"/>
-                  </a:schemeClr>
-                </a:lnRef>
-                <a:fillRef idx="1">
-                  <a:schemeClr val="accent1"/>
-                </a:fillRef>
-                <a:effectRef idx="0">
-                  <a:schemeClr val="accent1"/>
-                </a:effectRef>
-                <a:fontRef idx="minor">
-                  <a:schemeClr val="lt1"/>
-                </a:fontRef>
-              </p:style>
-              <p:txBody>
-                <a:bodyPr rtlCol="0" anchor="ctr"/>
-                <a:lstStyle/>
-                <a:p>
-                  <a:pPr algn="ctr"/>
-                  <a:endParaRPr lang="en-DK"/>
-                </a:p>
-              </p:txBody>
-            </p:sp>
-          </p:grpSp>
-        </p:grpSp>
-        <p:sp>
-          <p:nvSpPr>
-            <p:cNvPr id="17" name="TextBox 16">
-              <a:extLst>
-                <a:ext uri="{FF2B5EF4-FFF2-40B4-BE49-F238E27FC236}">
-                  <a16:creationId xmlns:a16="http://schemas.microsoft.com/office/drawing/2014/main" id="{13B25C3B-935B-2D44-1A53-1FC9E7B5B936}"/>
-                </a:ext>
-              </a:extLst>
-            </p:cNvPr>
-            <p:cNvSpPr txBox="1"/>
-            <p:nvPr/>
-          </p:nvSpPr>
-          <p:spPr>
-            <a:xfrm>
-              <a:off x="2346023" y="3288472"/>
-              <a:ext cx="4356429" cy="400110"/>
-            </a:xfrm>
-            <a:prstGeom prst="rect">
-              <a:avLst/>
-            </a:prstGeom>
-            <a:noFill/>
-          </p:spPr>
-          <p:txBody>
-            <a:bodyPr wrap="square" rtlCol="0">
-              <a:spAutoFit/>
-            </a:bodyPr>
-            <a:lstStyle/>
-            <a:p>
-              <a:pPr algn="just"/>
-              <a:r>
-                <a:rPr lang="da-DK" sz="2000" dirty="0">
+              <a:prstGeom prst="rect">
+                <a:avLst/>
+              </a:prstGeom>
+              <a:noFill/>
+            </p:spPr>
+            <p:txBody>
+              <a:bodyPr wrap="square" lIns="90000" rtlCol="0">
+                <a:noAutofit/>
+              </a:bodyPr>
+              <a:lstStyle/>
+              <a:p>
+                <a:pPr algn="just"/>
+                <a:r>
+                  <a:rPr lang="da-DK" sz="2200" dirty="0">
+                    <a:solidFill>
+                      <a:srgbClr val="63738F"/>
+                    </a:solidFill>
+                    <a:latin typeface="Inter" panose="02000503000000020004" pitchFamily="2" charset="0"/>
+                    <a:ea typeface="Inter" panose="02000503000000020004" pitchFamily="2" charset="0"/>
+                  </a:rPr>
+                  <a:t>Klarhed over din boligøkonomi</a:t>
+                </a:r>
+                <a:endParaRPr lang="en-DK" sz="2200" dirty="0">
                   <a:solidFill>
                     <a:srgbClr val="63738F"/>
                   </a:solidFill>
                   <a:latin typeface="Inter" panose="02000503000000020004" pitchFamily="2" charset="0"/>
                   <a:ea typeface="Inter" panose="02000503000000020004" pitchFamily="2" charset="0"/>
-                </a:rPr>
-                <a:t>Klarhed over din boligøkonomi</a:t>
-              </a:r>
-              <a:endParaRPr lang="en-DK" sz="2000" dirty="0">
-                <a:solidFill>
-                  <a:srgbClr val="63738F"/>
-                </a:solidFill>
-                <a:latin typeface="Inter" panose="02000503000000020004" pitchFamily="2" charset="0"/>
-                <a:ea typeface="Inter" panose="02000503000000020004" pitchFamily="2" charset="0"/>
-              </a:endParaRPr>
-            </a:p>
-          </p:txBody>
-        </p:sp>
+                </a:endParaRPr>
+              </a:p>
+            </p:txBody>
+          </p:sp>
+        </p:grpSp>
+        <p:pic>
+          <p:nvPicPr>
+            <p:cNvPr id="21" name="Graphic 20" descr="Apple with solid fill">
+              <a:extLst>
+                <a:ext uri="{FF2B5EF4-FFF2-40B4-BE49-F238E27FC236}">
+                  <a16:creationId xmlns:a16="http://schemas.microsoft.com/office/drawing/2014/main" id="{37E7564A-1DEF-7C53-6CC0-4B3F69CBD1C9}"/>
+                </a:ext>
+              </a:extLst>
+            </p:cNvPr>
+            <p:cNvPicPr>
+              <a:picLocks noChangeAspect="1"/>
+            </p:cNvPicPr>
+            <p:nvPr/>
+          </p:nvPicPr>
+          <p:blipFill>
+            <a:blip r:embed="rId2">
+              <a:extLst>
+                <a:ext uri="{96DAC541-7B7A-43D3-8B79-37D633B846F1}">
+                  <asvg:svgBlip xmlns:asvg="http://schemas.microsoft.com/office/drawing/2016/SVG/main" r:embed="rId3"/>
+                </a:ext>
+              </a:extLst>
+            </a:blip>
+            <a:stretch>
+              <a:fillRect/>
+            </a:stretch>
+          </p:blipFill>
+          <p:spPr>
+            <a:xfrm>
+              <a:off x="1002923" y="3451700"/>
+              <a:ext cx="607811" cy="607811"/>
+            </a:xfrm>
+            <a:prstGeom prst="rect">
+              <a:avLst/>
+            </a:prstGeom>
+          </p:spPr>
+        </p:pic>
       </p:grpSp>
     </p:spTree>
     <p:extLst>

</xml_diff>

<commit_message>
Beregnersektioner, artikler, realkredit/banklån uafhængige
Beregnere:
- Købspris/udbetaling, Finansiering (Realkreditlån), Finansiering (bolig-/banklån), Boligtype, El varme vand, Andre omkostninger
- Realkreditlån og udbetaling uafhængige; banklån = købspris − udbetaling − realkredit
- Lånebeløb realkredit med %-knapper (80/75/70/65); afdragsfrihed som rullemenu
- Banklån: beregnet beløb, altid Rente + Løbetid + Afdragsfrihed (som realkredit)
- Afdragsfrihed (Ja/Nej), 5 % min. udbetaling, 80 % max realkredit
- Resultatpanel: opdeling Realkreditlån / Bolig- banklån; PDF tilsvarende

Artikler:
- realkreditlan, vedligehold, eksisterende-pantebrev; artikel-plan i docs/

Diverse:
- Opdateret logo (public + Topbar størrelse), sitemap med nye artikler

Made-with: Cursor
</commit_message>
<xml_diff>
--- a/Brand Identity & Logo/Boligklarhed Logo PP.pptx
+++ b/Brand Identity & Logo/Boligklarhed Logo PP.pptx
@@ -7,14 +7,14 @@
   <p:sldIdLst>
     <p:sldId id="256" r:id="rId2"/>
   </p:sldIdLst>
-  <p:sldSz cx="6478588" cy="2879725"/>
+  <p:sldSz cx="5759450" cy="1439863"/>
   <p:notesSz cx="6858000" cy="9144000"/>
   <p:defaultTextStyle>
     <a:defPPr>
       <a:defRPr lang="en-DK"/>
     </a:defPPr>
-    <a:lvl1pPr marL="0" algn="l" defTabSz="598849" rtl="0" eaLnBrk="1" latinLnBrk="0" hangingPunct="1">
-      <a:defRPr sz="1178" kern="1200">
+    <a:lvl1pPr marL="0" algn="l" defTabSz="506806" rtl="0" eaLnBrk="1" latinLnBrk="0" hangingPunct="1">
+      <a:defRPr sz="997" kern="1200">
         <a:solidFill>
           <a:schemeClr val="tx1"/>
         </a:solidFill>
@@ -23,8 +23,8 @@
         <a:cs typeface="+mn-cs"/>
       </a:defRPr>
     </a:lvl1pPr>
-    <a:lvl2pPr marL="299426" algn="l" defTabSz="598849" rtl="0" eaLnBrk="1" latinLnBrk="0" hangingPunct="1">
-      <a:defRPr sz="1178" kern="1200">
+    <a:lvl2pPr marL="253404" algn="l" defTabSz="506806" rtl="0" eaLnBrk="1" latinLnBrk="0" hangingPunct="1">
+      <a:defRPr sz="997" kern="1200">
         <a:solidFill>
           <a:schemeClr val="tx1"/>
         </a:solidFill>
@@ -33,8 +33,8 @@
         <a:cs typeface="+mn-cs"/>
       </a:defRPr>
     </a:lvl2pPr>
-    <a:lvl3pPr marL="598849" algn="l" defTabSz="598849" rtl="0" eaLnBrk="1" latinLnBrk="0" hangingPunct="1">
-      <a:defRPr sz="1178" kern="1200">
+    <a:lvl3pPr marL="506806" algn="l" defTabSz="506806" rtl="0" eaLnBrk="1" latinLnBrk="0" hangingPunct="1">
+      <a:defRPr sz="997" kern="1200">
         <a:solidFill>
           <a:schemeClr val="tx1"/>
         </a:solidFill>
@@ -43,8 +43,8 @@
         <a:cs typeface="+mn-cs"/>
       </a:defRPr>
     </a:lvl3pPr>
-    <a:lvl4pPr marL="898275" algn="l" defTabSz="598849" rtl="0" eaLnBrk="1" latinLnBrk="0" hangingPunct="1">
-      <a:defRPr sz="1178" kern="1200">
+    <a:lvl4pPr marL="760210" algn="l" defTabSz="506806" rtl="0" eaLnBrk="1" latinLnBrk="0" hangingPunct="1">
+      <a:defRPr sz="997" kern="1200">
         <a:solidFill>
           <a:schemeClr val="tx1"/>
         </a:solidFill>
@@ -53,8 +53,8 @@
         <a:cs typeface="+mn-cs"/>
       </a:defRPr>
     </a:lvl4pPr>
-    <a:lvl5pPr marL="1197699" algn="l" defTabSz="598849" rtl="0" eaLnBrk="1" latinLnBrk="0" hangingPunct="1">
-      <a:defRPr sz="1178" kern="1200">
+    <a:lvl5pPr marL="1013613" algn="l" defTabSz="506806" rtl="0" eaLnBrk="1" latinLnBrk="0" hangingPunct="1">
+      <a:defRPr sz="997" kern="1200">
         <a:solidFill>
           <a:schemeClr val="tx1"/>
         </a:solidFill>
@@ -63,8 +63,8 @@
         <a:cs typeface="+mn-cs"/>
       </a:defRPr>
     </a:lvl5pPr>
-    <a:lvl6pPr marL="1497125" algn="l" defTabSz="598849" rtl="0" eaLnBrk="1" latinLnBrk="0" hangingPunct="1">
-      <a:defRPr sz="1178" kern="1200">
+    <a:lvl6pPr marL="1267017" algn="l" defTabSz="506806" rtl="0" eaLnBrk="1" latinLnBrk="0" hangingPunct="1">
+      <a:defRPr sz="997" kern="1200">
         <a:solidFill>
           <a:schemeClr val="tx1"/>
         </a:solidFill>
@@ -73,8 +73,8 @@
         <a:cs typeface="+mn-cs"/>
       </a:defRPr>
     </a:lvl6pPr>
-    <a:lvl7pPr marL="1796551" algn="l" defTabSz="598849" rtl="0" eaLnBrk="1" latinLnBrk="0" hangingPunct="1">
-      <a:defRPr sz="1178" kern="1200">
+    <a:lvl7pPr marL="1520421" algn="l" defTabSz="506806" rtl="0" eaLnBrk="1" latinLnBrk="0" hangingPunct="1">
+      <a:defRPr sz="997" kern="1200">
         <a:solidFill>
           <a:schemeClr val="tx1"/>
         </a:solidFill>
@@ -83,8 +83,8 @@
         <a:cs typeface="+mn-cs"/>
       </a:defRPr>
     </a:lvl7pPr>
-    <a:lvl8pPr marL="2095974" algn="l" defTabSz="598849" rtl="0" eaLnBrk="1" latinLnBrk="0" hangingPunct="1">
-      <a:defRPr sz="1178" kern="1200">
+    <a:lvl8pPr marL="1773823" algn="l" defTabSz="506806" rtl="0" eaLnBrk="1" latinLnBrk="0" hangingPunct="1">
+      <a:defRPr sz="997" kern="1200">
         <a:solidFill>
           <a:schemeClr val="tx1"/>
         </a:solidFill>
@@ -93,8 +93,8 @@
         <a:cs typeface="+mn-cs"/>
       </a:defRPr>
     </a:lvl8pPr>
-    <a:lvl9pPr marL="2395400" algn="l" defTabSz="598849" rtl="0" eaLnBrk="1" latinLnBrk="0" hangingPunct="1">
-      <a:defRPr sz="1178" kern="1200">
+    <a:lvl9pPr marL="2027227" algn="l" defTabSz="506806" rtl="0" eaLnBrk="1" latinLnBrk="0" hangingPunct="1">
+      <a:defRPr sz="997" kern="1200">
         <a:solidFill>
           <a:schemeClr val="tx1"/>
         </a:solidFill>
@@ -147,8 +147,8 @@
         </p:nvSpPr>
         <p:spPr>
           <a:xfrm>
-            <a:off x="809823" y="471289"/>
-            <a:ext cx="4858942" cy="1002571"/>
+            <a:off x="719931" y="235645"/>
+            <a:ext cx="4319588" cy="501286"/>
           </a:xfrm>
         </p:spPr>
         <p:txBody>
@@ -185,8 +185,8 @@
         </p:nvSpPr>
         <p:spPr>
           <a:xfrm>
-            <a:off x="809823" y="1512524"/>
-            <a:ext cx="4858942" cy="695267"/>
+            <a:off x="719931" y="756263"/>
+            <a:ext cx="4319588" cy="347634"/>
           </a:xfrm>
         </p:spPr>
         <p:txBody>
@@ -569,8 +569,8 @@
         </p:nvSpPr>
         <p:spPr>
           <a:xfrm>
-            <a:off x="4636240" y="153320"/>
-            <a:ext cx="1396946" cy="2440434"/>
+            <a:off x="4121607" y="76660"/>
+            <a:ext cx="1241882" cy="1220218"/>
           </a:xfrm>
         </p:spPr>
         <p:txBody>
@@ -603,8 +603,8 @@
         </p:nvSpPr>
         <p:spPr>
           <a:xfrm>
-            <a:off x="445405" y="153320"/>
-            <a:ext cx="4109853" cy="2440434"/>
+            <a:off x="395964" y="76660"/>
+            <a:ext cx="3653650" cy="1220218"/>
           </a:xfrm>
         </p:spPr>
         <p:txBody>
@@ -979,8 +979,8 @@
         </p:nvSpPr>
         <p:spPr>
           <a:xfrm>
-            <a:off x="442030" y="717933"/>
-            <a:ext cx="5587782" cy="1197885"/>
+            <a:off x="392964" y="358967"/>
+            <a:ext cx="4967525" cy="598943"/>
           </a:xfrm>
         </p:spPr>
         <p:txBody>
@@ -1017,8 +1017,8 @@
         </p:nvSpPr>
         <p:spPr>
           <a:xfrm>
-            <a:off x="442030" y="1927150"/>
-            <a:ext cx="5587782" cy="629939"/>
+            <a:off x="392964" y="963575"/>
+            <a:ext cx="4967525" cy="314970"/>
           </a:xfrm>
         </p:spPr>
         <p:txBody>
@@ -1284,8 +1284,8 @@
         </p:nvSpPr>
         <p:spPr>
           <a:xfrm>
-            <a:off x="445404" y="766593"/>
-            <a:ext cx="2753400" cy="1827159"/>
+            <a:off x="395963" y="383297"/>
+            <a:ext cx="2447766" cy="913580"/>
           </a:xfrm>
         </p:spPr>
         <p:txBody>
@@ -1347,8 +1347,8 @@
         </p:nvSpPr>
         <p:spPr>
           <a:xfrm>
-            <a:off x="3279786" y="766593"/>
-            <a:ext cx="2753400" cy="1827159"/>
+            <a:off x="2915722" y="383297"/>
+            <a:ext cx="2447766" cy="913580"/>
           </a:xfrm>
         </p:spPr>
         <p:txBody>
@@ -1523,8 +1523,8 @@
         </p:nvSpPr>
         <p:spPr>
           <a:xfrm>
-            <a:off x="446248" y="153320"/>
-            <a:ext cx="5587782" cy="556614"/>
+            <a:off x="396714" y="76660"/>
+            <a:ext cx="4967525" cy="278307"/>
           </a:xfrm>
         </p:spPr>
         <p:txBody>
@@ -1557,8 +1557,8 @@
         </p:nvSpPr>
         <p:spPr>
           <a:xfrm>
-            <a:off x="446247" y="705932"/>
-            <a:ext cx="2740747" cy="345967"/>
+            <a:off x="396713" y="352967"/>
+            <a:ext cx="2436518" cy="172984"/>
           </a:xfrm>
         </p:spPr>
         <p:txBody>
@@ -1628,8 +1628,8 @@
         </p:nvSpPr>
         <p:spPr>
           <a:xfrm>
-            <a:off x="446247" y="1051900"/>
-            <a:ext cx="2740747" cy="1547186"/>
+            <a:off x="396713" y="525950"/>
+            <a:ext cx="2436518" cy="773593"/>
           </a:xfrm>
         </p:spPr>
         <p:txBody>
@@ -1691,8 +1691,8 @@
         </p:nvSpPr>
         <p:spPr>
           <a:xfrm>
-            <a:off x="3279786" y="705932"/>
-            <a:ext cx="2754243" cy="345967"/>
+            <a:off x="2915723" y="352967"/>
+            <a:ext cx="2448516" cy="172984"/>
           </a:xfrm>
         </p:spPr>
         <p:txBody>
@@ -1762,8 +1762,8 @@
         </p:nvSpPr>
         <p:spPr>
           <a:xfrm>
-            <a:off x="3279786" y="1051900"/>
-            <a:ext cx="2754243" cy="1547186"/>
+            <a:off x="2915723" y="525950"/>
+            <a:ext cx="2448516" cy="773593"/>
           </a:xfrm>
         </p:spPr>
         <p:txBody>
@@ -2193,8 +2193,8 @@
         </p:nvSpPr>
         <p:spPr>
           <a:xfrm>
-            <a:off x="446248" y="191982"/>
-            <a:ext cx="2089513" cy="671936"/>
+            <a:off x="396714" y="95992"/>
+            <a:ext cx="1857572" cy="335968"/>
           </a:xfrm>
         </p:spPr>
         <p:txBody>
@@ -2231,8 +2231,8 @@
         </p:nvSpPr>
         <p:spPr>
           <a:xfrm>
-            <a:off x="2754244" y="414628"/>
-            <a:ext cx="3279786" cy="2046471"/>
+            <a:off x="2448517" y="207315"/>
+            <a:ext cx="2915722" cy="1023236"/>
           </a:xfrm>
         </p:spPr>
         <p:txBody>
@@ -2322,8 +2322,8 @@
         </p:nvSpPr>
         <p:spPr>
           <a:xfrm>
-            <a:off x="446248" y="863918"/>
-            <a:ext cx="2089513" cy="1600514"/>
+            <a:off x="396714" y="431960"/>
+            <a:ext cx="1857572" cy="800257"/>
           </a:xfrm>
         </p:spPr>
         <p:txBody>
@@ -2506,8 +2506,8 @@
         </p:nvSpPr>
         <p:spPr>
           <a:xfrm>
-            <a:off x="446248" y="191982"/>
-            <a:ext cx="2089513" cy="671936"/>
+            <a:off x="396714" y="95992"/>
+            <a:ext cx="1857572" cy="335968"/>
           </a:xfrm>
         </p:spPr>
         <p:txBody>
@@ -2544,8 +2544,8 @@
         </p:nvSpPr>
         <p:spPr>
           <a:xfrm>
-            <a:off x="2754244" y="414628"/>
-            <a:ext cx="3279786" cy="2046471"/>
+            <a:off x="2448517" y="207315"/>
+            <a:ext cx="2915722" cy="1023236"/>
           </a:xfrm>
         </p:spPr>
         <p:txBody>
@@ -2611,8 +2611,8 @@
         </p:nvSpPr>
         <p:spPr>
           <a:xfrm>
-            <a:off x="446248" y="863918"/>
-            <a:ext cx="2089513" cy="1600514"/>
+            <a:off x="396714" y="431960"/>
+            <a:ext cx="1857572" cy="800257"/>
           </a:xfrm>
         </p:spPr>
         <p:txBody>
@@ -2800,8 +2800,8 @@
         </p:nvSpPr>
         <p:spPr>
           <a:xfrm>
-            <a:off x="445403" y="153320"/>
-            <a:ext cx="5587782" cy="556614"/>
+            <a:off x="395963" y="76660"/>
+            <a:ext cx="4967525" cy="278307"/>
           </a:xfrm>
           <a:prstGeom prst="rect">
             <a:avLst/>
@@ -2839,8 +2839,8 @@
         </p:nvSpPr>
         <p:spPr>
           <a:xfrm>
-            <a:off x="445403" y="766593"/>
-            <a:ext cx="5587782" cy="1827159"/>
+            <a:off x="395963" y="383297"/>
+            <a:ext cx="4967525" cy="913580"/>
           </a:xfrm>
           <a:prstGeom prst="rect">
             <a:avLst/>
@@ -2907,8 +2907,8 @@
         </p:nvSpPr>
         <p:spPr>
           <a:xfrm>
-            <a:off x="445404" y="2669080"/>
-            <a:ext cx="1457682" cy="153319"/>
+            <a:off x="395963" y="1334540"/>
+            <a:ext cx="1295876" cy="76660"/>
           </a:xfrm>
           <a:prstGeom prst="rect">
             <a:avLst/>
@@ -2954,8 +2954,8 @@
         </p:nvSpPr>
         <p:spPr>
           <a:xfrm>
-            <a:off x="2146033" y="2669080"/>
-            <a:ext cx="2186523" cy="153319"/>
+            <a:off x="1907819" y="1334540"/>
+            <a:ext cx="1943814" cy="76660"/>
           </a:xfrm>
           <a:prstGeom prst="rect">
             <a:avLst/>
@@ -2997,8 +2997,8 @@
         </p:nvSpPr>
         <p:spPr>
           <a:xfrm>
-            <a:off x="4575505" y="2669080"/>
-            <a:ext cx="1457682" cy="153319"/>
+            <a:off x="4067614" y="1334540"/>
+            <a:ext cx="1295876" cy="76660"/>
           </a:xfrm>
           <a:prstGeom prst="rect">
             <a:avLst/>
@@ -3361,7 +3361,7 @@
         </p:nvGrpSpPr>
         <p:grpSpPr>
           <a:xfrm>
-            <a:off x="526297" y="846292"/>
+            <a:off x="166730" y="126361"/>
             <a:ext cx="5425999" cy="1187140"/>
             <a:chOff x="886658" y="3053222"/>
             <a:chExt cx="5425999" cy="1187140"/>
@@ -3593,7 +3593,7 @@
               <a:p>
                 <a:pPr algn="just"/>
                 <a:r>
-                  <a:rPr lang="da-DK" sz="2200" dirty="0">
+                  <a:rPr lang="da-DK" sz="2280" dirty="0">
                     <a:solidFill>
                       <a:srgbClr val="63738F"/>
                     </a:solidFill>
@@ -3602,7 +3602,7 @@
                   </a:rPr>
                   <a:t>Klarhed over din boligøkonomi</a:t>
                 </a:r>
-                <a:endParaRPr lang="en-DK" sz="2200" dirty="0">
+                <a:endParaRPr lang="en-DK" sz="2280" dirty="0">
                   <a:solidFill>
                     <a:srgbClr val="63738F"/>
                   </a:solidFill>

</xml_diff>